<commit_message>
docs: apply HeyPay branding to pitch deck v3
Replaces placeholder image boxes with the real brand assets: the hero image
(homepage/hero.jpg) full-bleed on the title slide with a legibility scrim and
a logo + wordmark lockup, and the HeyPay logo mark (homepage/logo.jpg, prepped
to a transparent-corner PNG) as a corner mark on every content slide and a
faint watermark on the problem slide. Keeps the BRAND.md color/type system
(cyan/orange, Lexend/Inter) and the GTM tier pills.

Claude-Session: https://claude.ai/code/session_0111nXegb187pdaFhyoX5DwB
</commit_message>
<xml_diff>
--- a/docs/pitch-deck-v3.pptx
+++ b/docs/pitch-deck-v3.pptx
@@ -4285,7 +4285,7 @@
     <p:bg>
       <p:bgPr>
         <a:solidFill>
-          <a:srgbClr val="FCF9F8"/>
+          <a:srgbClr val="1D1B1A"/>
         </a:solidFill>
         <a:effectLst/>
       </p:bgPr>
@@ -4297,27 +4297,51 @@
         <p:nvPr/>
       </p:nvGrpSpPr>
       <p:grpSpPr/>
-      <p:sp>
-        <p:nvSpPr>
-          <p:cNvPr id="2" name="FullSlideImage"/>
+      <p:pic>
+        <p:nvPicPr>
+          <p:cNvPr id="2" name="Picture 1" descr="hero_16x9.jpg"/>
+          <p:cNvPicPr>
+            <a:picLocks noChangeAspect="1"/>
+          </p:cNvPicPr>
+          <p:nvPr/>
+        </p:nvPicPr>
+        <p:blipFill>
+          <a:blip r:embed="rId2"/>
+          <a:stretch>
+            <a:fillRect/>
+          </a:stretch>
+        </p:blipFill>
+        <p:spPr>
+          <a:xfrm>
+            <a:off x="0" y="0"/>
+            <a:ext cx="12192000" cy="6858000"/>
+          </a:xfrm>
+          <a:prstGeom prst="rect">
+            <a:avLst/>
+          </a:prstGeom>
+        </p:spPr>
+      </p:pic>
+      <p:sp>
+        <p:nvSpPr>
+          <p:cNvPr id="3" name="Rectangle 2"/>
           <p:cNvSpPr/>
           <p:nvPr/>
         </p:nvSpPr>
         <p:spPr>
           <a:xfrm>
-            <a:off x="0" y="0"/>
-            <a:ext cx="12192000" cy="6858000"/>
+            <a:off x="0" y="4300000"/>
+            <a:ext cx="12192000" cy="2558000"/>
           </a:xfrm>
           <a:prstGeom prst="rect">
             <a:avLst/>
           </a:prstGeom>
           <a:solidFill>
-            <a:srgbClr val="B2EBF2"/>
+            <a:srgbClr val="1D1B1A">
+              <a:alpha val="62000"/>
+            </a:srgbClr>
           </a:solidFill>
-          <a:ln w="12700">
-            <a:solidFill>
-              <a:srgbClr val="00BCD4"/>
-            </a:solidFill>
+          <a:ln>
+            <a:noFill/>
           </a:ln>
           <a:effectLst/>
         </p:spPr>
@@ -4336,65 +4360,63 @@
           </a:fontRef>
         </p:style>
         <p:txBody>
-          <a:bodyPr rtlCol="0" anchor="ctr" wrap="square"/>
+          <a:bodyPr rtlCol="0" anchor="ctr"/>
           <a:lstStyle/>
           <a:p>
             <a:pPr algn="ctr"/>
-            <a:r>
-              <a:rPr sz="2000" i="1">
-                <a:solidFill>
-                  <a:srgbClr val="0097A7"/>
-                </a:solidFill>
-                <a:latin typeface="Inter"/>
-              </a:rPr>
-              <a:t>[FULL-SLIDE IMAGE — see image prompt #1: Manila street-market hero shot]</a:t>
-            </a:r>
-          </a:p>
-        </p:txBody>
-      </p:sp>
-      <p:sp>
-        <p:nvSpPr>
-          <p:cNvPr id="3" name="Rectangle 2"/>
-          <p:cNvSpPr/>
+          </a:p>
+        </p:txBody>
+      </p:sp>
+      <p:pic>
+        <p:nvPicPr>
+          <p:cNvPr id="4" name="Picture 3" descr="logo_mark.png"/>
+          <p:cNvPicPr>
+            <a:picLocks noChangeAspect="1"/>
+          </p:cNvPicPr>
           <p:nvPr/>
-        </p:nvSpPr>
-        <p:spPr>
-          <a:xfrm>
-            <a:off x="685800" y="2250000"/>
-            <a:ext cx="10820400" cy="1000000"/>
+        </p:nvPicPr>
+        <p:blipFill>
+          <a:blip r:embed="rId3"/>
+          <a:stretch>
+            <a:fillRect/>
+          </a:stretch>
+        </p:blipFill>
+        <p:spPr>
+          <a:xfrm>
+            <a:off x="685800" y="4650000"/>
+            <a:ext cx="1000000" cy="1000000"/>
+          </a:xfrm>
+          <a:prstGeom prst="rect">
+            <a:avLst/>
+          </a:prstGeom>
+        </p:spPr>
+      </p:pic>
+      <p:sp>
+        <p:nvSpPr>
+          <p:cNvPr id="5" name="TextBox 4"/>
+          <p:cNvSpPr txBox="1"/>
+          <p:nvPr/>
+        </p:nvSpPr>
+        <p:spPr>
+          <a:xfrm>
+            <a:off x="1865800" y="4620000"/>
+            <a:ext cx="6000000" cy="1080000"/>
           </a:xfrm>
           <a:prstGeom prst="rect">
             <a:avLst/>
           </a:prstGeom>
           <a:noFill/>
-          <a:ln>
-            <a:noFill/>
-          </a:ln>
-          <a:effectLst/>
-        </p:spPr>
-        <p:style>
-          <a:lnRef idx="1">
-            <a:schemeClr val="accent1"/>
-          </a:lnRef>
-          <a:fillRef idx="3">
-            <a:schemeClr val="accent1"/>
-          </a:fillRef>
-          <a:effectRef idx="2">
-            <a:schemeClr val="accent1"/>
-          </a:effectRef>
-          <a:fontRef idx="minor">
-            <a:schemeClr val="lt1"/>
-          </a:fontRef>
-        </p:style>
-        <p:txBody>
-          <a:bodyPr rtlCol="0" anchor="ctr"/>
-          <a:lstStyle/>
-          <a:p>
-            <a:pPr algn="ctr"/>
-            <a:r>
-              <a:rPr sz="6000" b="1">
-                <a:solidFill>
-                  <a:srgbClr val="00BCD4"/>
+        </p:spPr>
+        <p:txBody>
+          <a:bodyPr wrap="square" anchor="ctr">
+            <a:spAutoFit/>
+          </a:bodyPr>
+          <a:lstStyle/>
+          <a:p>
+            <a:r>
+              <a:rPr sz="5400" b="1">
+                <a:solidFill>
+                  <a:srgbClr val="FFFFFF"/>
                 </a:solidFill>
                 <a:latin typeface="Lexend"/>
               </a:rPr>
@@ -4405,117 +4427,85 @@
       </p:sp>
       <p:sp>
         <p:nvSpPr>
-          <p:cNvPr id="4" name="Rectangle 3"/>
-          <p:cNvSpPr/>
+          <p:cNvPr id="6" name="TextBox 5"/>
+          <p:cNvSpPr txBox="1"/>
           <p:nvPr/>
         </p:nvSpPr>
         <p:spPr>
           <a:xfrm>
-            <a:off x="685800" y="3350000"/>
-            <a:ext cx="10820400" cy="2000000"/>
+            <a:off x="685800" y="5750000"/>
+            <a:ext cx="10820400" cy="1000000"/>
           </a:xfrm>
           <a:prstGeom prst="rect">
             <a:avLst/>
           </a:prstGeom>
           <a:noFill/>
-          <a:ln>
-            <a:noFill/>
-          </a:ln>
-          <a:effectLst/>
-        </p:spPr>
-        <p:style>
-          <a:lnRef idx="1">
-            <a:schemeClr val="accent1"/>
-          </a:lnRef>
-          <a:fillRef idx="3">
-            <a:schemeClr val="accent1"/>
-          </a:fillRef>
-          <a:effectRef idx="2">
-            <a:schemeClr val="accent1"/>
-          </a:effectRef>
-          <a:fontRef idx="minor">
-            <a:schemeClr val="lt1"/>
-          </a:fontRef>
-        </p:style>
-        <p:txBody>
-          <a:bodyPr rtlCol="0" anchor="ctr" wrap="square"/>
-          <a:lstStyle/>
-          <a:p>
-            <a:pPr algn="ctr">
+        </p:spPr>
+        <p:txBody>
+          <a:bodyPr wrap="square">
+            <a:spAutoFit/>
+          </a:bodyPr>
+          <a:lstStyle/>
+          <a:p>
+            <a:pPr>
               <a:spcAft>
-                <a:spcPts val="800"/>
+                <a:spcPts val="600"/>
               </a:spcAft>
             </a:pPr>
             <a:r>
-              <a:rPr sz="2800" i="0">
-                <a:solidFill>
-                  <a:srgbClr val="1D1B1A"/>
-                </a:solidFill>
-                <a:latin typeface="Inter"/>
-              </a:rPr>
-              <a:t>Pay any QRPH merchant with your Stellar balance —</a:t>
+              <a:rPr sz="2200" i="0">
+                <a:solidFill>
+                  <a:srgbClr val="FFFFFF"/>
+                </a:solidFill>
+                <a:latin typeface="Inter"/>
+              </a:rPr>
+              <a:t>Pay any QRPH merchant with your Stellar balance — </a:t>
             </a:r>
           </a:p>
           <a:p>
             <a:pPr>
               <a:spcAft>
-                <a:spcPts val="800"/>
+                <a:spcPts val="600"/>
               </a:spcAft>
             </a:pPr>
             <a:r>
-              <a:rPr sz="2800" i="1">
-                <a:solidFill>
-                  <a:srgbClr val="4E4643"/>
-                </a:solidFill>
-                <a:latin typeface="Inter"/>
-              </a:rPr>
-              <a:t>built for the Philippines, designed to plug into Stellar's global rails.</a:t>
+              <a:rPr sz="1800" i="1">
+                <a:solidFill>
+                  <a:srgbClr val="B2EBF2"/>
+                </a:solidFill>
+                <a:latin typeface="Inter"/>
+              </a:rPr>
+              <a:t>Built for the Philippines, designed to plug into Stellar's global rails.</a:t>
             </a:r>
           </a:p>
           <a:p>
             <a:pPr>
               <a:spcAft>
-                <a:spcPts val="800"/>
+                <a:spcPts val="600"/>
               </a:spcAft>
             </a:pPr>
             <a:r>
-              <a:rPr sz="1600" i="0">
-                <a:solidFill>
-                  <a:srgbClr val="4E4643"/>
-                </a:solidFill>
-                <a:latin typeface="Inter"/>
-              </a:rPr>
-              <a:t>Project Lead: [NAME]</a:t>
-            </a:r>
-          </a:p>
-          <a:p>
-            <a:pPr>
-              <a:spcAft>
-                <a:spcPts val="800"/>
-              </a:spcAft>
-            </a:pPr>
-            <a:r>
-              <a:rPr sz="1600" i="0">
-                <a:solidFill>
-                  <a:srgbClr val="4E4643"/>
-                </a:solidFill>
-                <a:latin typeface="Inter"/>
-              </a:rPr>
-              <a:t>Team: [PLACEHOLDER: team name]</a:t>
-            </a:r>
-          </a:p>
-        </p:txBody>
-      </p:sp>
-      <p:sp>
-        <p:nvSpPr>
-          <p:cNvPr id="5" name="TextBox 4"/>
+              <a:rPr sz="1400" i="0">
+                <a:solidFill>
+                  <a:srgbClr val="B2EBF2"/>
+                </a:solidFill>
+                <a:latin typeface="Inter"/>
+              </a:rPr>
+              <a:t>Project Lead: [NAME]   ·   Team: [PLACEHOLDER: team name]</a:t>
+            </a:r>
+          </a:p>
+        </p:txBody>
+      </p:sp>
+      <p:sp>
+        <p:nvSpPr>
+          <p:cNvPr id="7" name="TextBox 6"/>
           <p:cNvSpPr txBox="1"/>
           <p:nvPr/>
         </p:nvSpPr>
         <p:spPr>
           <a:xfrm>
-            <a:off x="685800" y="6458000"/>
-            <a:ext cx="10820400" cy="300000"/>
+            <a:off x="10706200" y="6458000"/>
+            <a:ext cx="800000" cy="300000"/>
           </a:xfrm>
           <a:prstGeom prst="rect">
             <a:avLst/>
@@ -4528,46 +4518,11 @@
           </a:bodyPr>
           <a:lstStyle/>
           <a:p>
-            <a:pPr algn="l"/>
-            <a:r>
-              <a:rPr sz="1100" b="1">
-                <a:solidFill>
-                  <a:srgbClr val="4E4643"/>
-                </a:solidFill>
-                <a:latin typeface="Lexend"/>
-              </a:rPr>
-              <a:t>HeyPay</a:t>
-            </a:r>
-          </a:p>
-        </p:txBody>
-      </p:sp>
-      <p:sp>
-        <p:nvSpPr>
-          <p:cNvPr id="6" name="TextBox 5"/>
-          <p:cNvSpPr txBox="1"/>
-          <p:nvPr/>
-        </p:nvSpPr>
-        <p:spPr>
-          <a:xfrm>
-            <a:off x="10706200" y="6458000"/>
-            <a:ext cx="800000" cy="300000"/>
-          </a:xfrm>
-          <a:prstGeom prst="rect">
-            <a:avLst/>
-          </a:prstGeom>
-          <a:noFill/>
-        </p:spPr>
-        <p:txBody>
-          <a:bodyPr wrap="none" lIns="0" tIns="0">
-            <a:spAutoFit/>
-          </a:bodyPr>
-          <a:lstStyle/>
-          <a:p>
             <a:pPr algn="r"/>
             <a:r>
               <a:rPr sz="1100">
                 <a:solidFill>
-                  <a:srgbClr val="4E4643"/>
+                  <a:srgbClr val="FFFFFF"/>
                 </a:solidFill>
                 <a:latin typeface="Inter"/>
               </a:rPr>
@@ -4611,7 +4566,7 @@
         <p:spPr>
           <a:xfrm>
             <a:off x="685800" y="400000"/>
-            <a:ext cx="10820400" cy="1000000"/>
+            <a:ext cx="10820400" cy="350000"/>
           </a:xfrm>
           <a:prstGeom prst="rect">
             <a:avLst/>
@@ -4619,6 +4574,40 @@
           <a:noFill/>
         </p:spPr>
         <p:txBody>
+          <a:bodyPr wrap="none" lIns="0">
+            <a:spAutoFit/>
+          </a:bodyPr>
+          <a:lstStyle/>
+          <a:p>
+            <a:r>
+              <a:rPr sz="1300" b="1" spc="150">
+                <a:solidFill>
+                  <a:srgbClr val="FF9800"/>
+                </a:solidFill>
+                <a:latin typeface="Lexend"/>
+              </a:rPr>
+              <a:t>PHILIPPINES → APAC → GLOBAL</a:t>
+            </a:r>
+          </a:p>
+        </p:txBody>
+      </p:sp>
+      <p:sp>
+        <p:nvSpPr>
+          <p:cNvPr id="3" name="TextBox 2"/>
+          <p:cNvSpPr txBox="1"/>
+          <p:nvPr/>
+        </p:nvSpPr>
+        <p:spPr>
+          <a:xfrm>
+            <a:off x="685800" y="780000"/>
+            <a:ext cx="10820400" cy="1000000"/>
+          </a:xfrm>
+          <a:prstGeom prst="rect">
+            <a:avLst/>
+          </a:prstGeom>
+          <a:noFill/>
+        </p:spPr>
+        <p:txBody>
           <a:bodyPr wrap="square" lIns="0">
             <a:spAutoFit/>
           </a:bodyPr>
@@ -4631,14 +4620,14 @@
                 </a:solidFill>
                 <a:latin typeface="Lexend"/>
               </a:rPr>
-              <a:t>Go-To-Market: Philippines → APAC → Global</a:t>
-            </a:r>
-          </a:p>
-        </p:txBody>
-      </p:sp>
-      <p:sp>
-        <p:nvSpPr>
-          <p:cNvPr id="3" name="Rounded Rectangle 2"/>
+              <a:t>Go-To-Market</a:t>
+            </a:r>
+          </a:p>
+        </p:txBody>
+      </p:sp>
+      <p:sp>
+        <p:nvSpPr>
+          <p:cNvPr id="4" name="Rounded Rectangle 3"/>
           <p:cNvSpPr/>
           <p:nvPr/>
         </p:nvSpPr>
@@ -4693,7 +4682,7 @@
       </p:sp>
       <p:sp>
         <p:nvSpPr>
-          <p:cNvPr id="4" name="Rounded Rectangle 3"/>
+          <p:cNvPr id="5" name="Rounded Rectangle 4"/>
           <p:cNvSpPr/>
           <p:nvPr/>
         </p:nvSpPr>
@@ -4748,7 +4737,7 @@
       </p:sp>
       <p:sp>
         <p:nvSpPr>
-          <p:cNvPr id="5" name="Rounded Rectangle 4"/>
+          <p:cNvPr id="6" name="Rounded Rectangle 5"/>
           <p:cNvSpPr/>
           <p:nvPr/>
         </p:nvSpPr>
@@ -4803,7 +4792,7 @@
       </p:sp>
       <p:sp>
         <p:nvSpPr>
-          <p:cNvPr id="6" name="TextBox 5"/>
+          <p:cNvPr id="7" name="TextBox 6"/>
           <p:cNvSpPr txBox="1"/>
           <p:nvPr/>
         </p:nvSpPr>
@@ -4937,14 +4926,14 @@
       </p:sp>
       <p:sp>
         <p:nvSpPr>
-          <p:cNvPr id="7" name="TextBox 6"/>
+          <p:cNvPr id="8" name="TextBox 7"/>
           <p:cNvSpPr txBox="1"/>
           <p:nvPr/>
         </p:nvSpPr>
         <p:spPr>
           <a:xfrm>
             <a:off x="685800" y="6458000"/>
-            <a:ext cx="10820400" cy="300000"/>
+            <a:ext cx="3000000" cy="300000"/>
           </a:xfrm>
           <a:prstGeom prst="rect">
             <a:avLst/>
@@ -4972,7 +4961,7 @@
       </p:sp>
       <p:sp>
         <p:nvSpPr>
-          <p:cNvPr id="8" name="TextBox 7"/>
+          <p:cNvPr id="9" name="TextBox 8"/>
           <p:cNvSpPr txBox="1"/>
           <p:nvPr/>
         </p:nvSpPr>
@@ -5005,6 +4994,30 @@
           </a:p>
         </p:txBody>
       </p:sp>
+      <p:pic>
+        <p:nvPicPr>
+          <p:cNvPr id="10" name="Picture 9" descr="logo_mark.png"/>
+          <p:cNvPicPr>
+            <a:picLocks noChangeAspect="1"/>
+          </p:cNvPicPr>
+          <p:nvPr/>
+        </p:nvPicPr>
+        <p:blipFill>
+          <a:blip r:embed="rId2"/>
+          <a:stretch>
+            <a:fillRect/>
+          </a:stretch>
+        </p:blipFill>
+        <p:spPr>
+          <a:xfrm>
+            <a:off x="10986200" y="360000"/>
+            <a:ext cx="520000" cy="520000"/>
+          </a:xfrm>
+          <a:prstGeom prst="rect">
+            <a:avLst/>
+          </a:prstGeom>
+        </p:spPr>
+      </p:pic>
     </p:spTree>
   </p:cSld>
   <p:clrMapOvr>
@@ -5316,7 +5329,7 @@
         <p:spPr>
           <a:xfrm>
             <a:off x="685800" y="6458000"/>
-            <a:ext cx="10820400" cy="300000"/>
+            <a:ext cx="3000000" cy="300000"/>
           </a:xfrm>
           <a:prstGeom prst="rect">
             <a:avLst/>
@@ -5377,6 +5390,30 @@
           </a:p>
         </p:txBody>
       </p:sp>
+      <p:pic>
+        <p:nvPicPr>
+          <p:cNvPr id="7" name="Picture 6" descr="logo_mark.png"/>
+          <p:cNvPicPr>
+            <a:picLocks noChangeAspect="1"/>
+          </p:cNvPicPr>
+          <p:nvPr/>
+        </p:nvPicPr>
+        <p:blipFill>
+          <a:blip r:embed="rId2"/>
+          <a:stretch>
+            <a:fillRect/>
+          </a:stretch>
+        </p:blipFill>
+        <p:spPr>
+          <a:xfrm>
+            <a:off x="10986200" y="360000"/>
+            <a:ext cx="520000" cy="520000"/>
+          </a:xfrm>
+          <a:prstGeom prst="rect">
+            <a:avLst/>
+          </a:prstGeom>
+        </p:spPr>
+      </p:pic>
     </p:spTree>
   </p:cSld>
   <p:clrMapOvr>
@@ -5627,7 +5664,7 @@
         <p:spPr>
           <a:xfrm>
             <a:off x="685800" y="6458000"/>
-            <a:ext cx="10820400" cy="300000"/>
+            <a:ext cx="3000000" cy="300000"/>
           </a:xfrm>
           <a:prstGeom prst="rect">
             <a:avLst/>
@@ -5688,6 +5725,30 @@
           </a:p>
         </p:txBody>
       </p:sp>
+      <p:pic>
+        <p:nvPicPr>
+          <p:cNvPr id="6" name="Picture 5" descr="logo_mark.png"/>
+          <p:cNvPicPr>
+            <a:picLocks noChangeAspect="1"/>
+          </p:cNvPicPr>
+          <p:nvPr/>
+        </p:nvPicPr>
+        <p:blipFill>
+          <a:blip r:embed="rId2"/>
+          <a:stretch>
+            <a:fillRect/>
+          </a:stretch>
+        </p:blipFill>
+        <p:spPr>
+          <a:xfrm>
+            <a:off x="10986200" y="360000"/>
+            <a:ext cx="520000" cy="520000"/>
+          </a:xfrm>
+          <a:prstGeom prst="rect">
+            <a:avLst/>
+          </a:prstGeom>
+        </p:spPr>
+      </p:pic>
     </p:spTree>
   </p:cSld>
   <p:clrMapOvr>
@@ -5729,12 +5790,10 @@
             <a:avLst/>
           </a:prstGeom>
           <a:solidFill>
-            <a:srgbClr val="B2EBF2"/>
+            <a:srgbClr val="1D1B1A"/>
           </a:solidFill>
-          <a:ln w="12700">
-            <a:solidFill>
-              <a:srgbClr val="00BCD4"/>
-            </a:solidFill>
+          <a:ln>
+            <a:noFill/>
           </a:ln>
           <a:effectLst/>
         </p:spPr>
@@ -5753,14 +5812,64 @@
           </a:fontRef>
         </p:style>
         <p:txBody>
-          <a:bodyPr rtlCol="0" anchor="ctr" wrap="square"/>
+          <a:bodyPr rtlCol="0" anchor="ctr"/>
           <a:lstStyle/>
           <a:p>
             <a:pPr algn="ctr"/>
-            <a:r>
-              <a:rPr sz="2000" i="1">
-                <a:solidFill>
-                  <a:srgbClr val="0097A7"/>
+          </a:p>
+        </p:txBody>
+      </p:sp>
+      <p:pic>
+        <p:nvPicPr>
+          <p:cNvPr id="3" name="Picture 2" descr="logo_mark.png"/>
+          <p:cNvPicPr>
+            <a:picLocks noChangeAspect="1"/>
+          </p:cNvPicPr>
+          <p:nvPr/>
+        </p:nvPicPr>
+        <p:blipFill>
+          <a:blip r:embed="rId2"/>
+          <a:stretch>
+            <a:fillRect/>
+          </a:stretch>
+        </p:blipFill>
+        <p:spPr>
+          <a:xfrm>
+            <a:off x="4796000" y="1829000"/>
+            <a:ext cx="2600000" cy="2600000"/>
+          </a:xfrm>
+          <a:prstGeom prst="rect">
+            <a:avLst/>
+          </a:prstGeom>
+        </p:spPr>
+      </p:pic>
+      <p:sp>
+        <p:nvSpPr>
+          <p:cNvPr id="4" name="TextBox 3"/>
+          <p:cNvSpPr txBox="1"/>
+          <p:nvPr/>
+        </p:nvSpPr>
+        <p:spPr>
+          <a:xfrm>
+            <a:off x="685800" y="4900000"/>
+            <a:ext cx="10820400" cy="500000"/>
+          </a:xfrm>
+          <a:prstGeom prst="rect">
+            <a:avLst/>
+          </a:prstGeom>
+          <a:noFill/>
+        </p:spPr>
+        <p:txBody>
+          <a:bodyPr wrap="square">
+            <a:spAutoFit/>
+          </a:bodyPr>
+          <a:lstStyle/>
+          <a:p>
+            <a:pPr algn="ctr"/>
+            <a:r>
+              <a:rPr sz="1500" i="1">
+                <a:solidFill>
+                  <a:srgbClr val="00BCD4"/>
                 </a:solidFill>
                 <a:latin typeface="Inter"/>
               </a:rPr>
@@ -5771,7 +5880,7 @@
       </p:sp>
       <p:sp>
         <p:nvSpPr>
-          <p:cNvPr id="3" name="Rectangle 2"/>
+          <p:cNvPr id="5" name="Rectangle 4"/>
           <p:cNvSpPr/>
           <p:nvPr/>
         </p:nvSpPr>
@@ -5822,14 +5931,14 @@
       </p:sp>
       <p:sp>
         <p:nvSpPr>
-          <p:cNvPr id="4" name="Rectangle 3"/>
+          <p:cNvPr id="6" name="Rectangle 5"/>
           <p:cNvSpPr/>
           <p:nvPr/>
         </p:nvSpPr>
         <p:spPr>
           <a:xfrm>
-            <a:off x="685800" y="5500000"/>
-            <a:ext cx="10820400" cy="900000"/>
+            <a:off x="685800" y="5600000"/>
+            <a:ext cx="10820400" cy="700000"/>
           </a:xfrm>
           <a:prstGeom prst="rect">
             <a:avLst/>
@@ -5862,7 +5971,7 @@
             <a:r>
               <a:rPr sz="2200">
                 <a:solidFill>
-                  <a:srgbClr val="1D1B1A"/>
+                  <a:srgbClr val="B2EBF2"/>
                 </a:solidFill>
                 <a:latin typeface="Inter"/>
               </a:rPr>
@@ -5873,14 +5982,14 @@
       </p:sp>
       <p:sp>
         <p:nvSpPr>
-          <p:cNvPr id="5" name="TextBox 4"/>
+          <p:cNvPr id="7" name="TextBox 6"/>
           <p:cNvSpPr txBox="1"/>
           <p:nvPr/>
         </p:nvSpPr>
         <p:spPr>
           <a:xfrm>
             <a:off x="685800" y="6458000"/>
-            <a:ext cx="10820400" cy="300000"/>
+            <a:ext cx="3000000" cy="300000"/>
           </a:xfrm>
           <a:prstGeom prst="rect">
             <a:avLst/>
@@ -5897,7 +6006,7 @@
             <a:r>
               <a:rPr sz="1100" b="1">
                 <a:solidFill>
-                  <a:srgbClr val="4E4643"/>
+                  <a:srgbClr val="FFFFFF"/>
                 </a:solidFill>
                 <a:latin typeface="Lexend"/>
               </a:rPr>
@@ -5908,7 +6017,7 @@
       </p:sp>
       <p:sp>
         <p:nvSpPr>
-          <p:cNvPr id="6" name="TextBox 5"/>
+          <p:cNvPr id="8" name="TextBox 7"/>
           <p:cNvSpPr txBox="1"/>
           <p:nvPr/>
         </p:nvSpPr>
@@ -5932,7 +6041,7 @@
             <a:r>
               <a:rPr sz="1100">
                 <a:solidFill>
-                  <a:srgbClr val="4E4643"/>
+                  <a:srgbClr val="FFFFFF"/>
                 </a:solidFill>
                 <a:latin typeface="Inter"/>
               </a:rPr>
@@ -6181,7 +6290,7 @@
         <p:spPr>
           <a:xfrm>
             <a:off x="685800" y="6458000"/>
-            <a:ext cx="10820400" cy="300000"/>
+            <a:ext cx="3000000" cy="300000"/>
           </a:xfrm>
           <a:prstGeom prst="rect">
             <a:avLst/>
@@ -6242,6 +6351,30 @@
           </a:p>
         </p:txBody>
       </p:sp>
+      <p:pic>
+        <p:nvPicPr>
+          <p:cNvPr id="6" name="Picture 5" descr="logo_mark.png"/>
+          <p:cNvPicPr>
+            <a:picLocks noChangeAspect="1"/>
+          </p:cNvPicPr>
+          <p:nvPr/>
+        </p:nvPicPr>
+        <p:blipFill>
+          <a:blip r:embed="rId2"/>
+          <a:stretch>
+            <a:fillRect/>
+          </a:stretch>
+        </p:blipFill>
+        <p:spPr>
+          <a:xfrm>
+            <a:off x="10986200" y="360000"/>
+            <a:ext cx="520000" cy="520000"/>
+          </a:xfrm>
+          <a:prstGeom prst="rect">
+            <a:avLst/>
+          </a:prstGeom>
+        </p:spPr>
+      </p:pic>
     </p:spTree>
   </p:cSld>
   <p:clrMapOvr>
@@ -6482,7 +6615,7 @@
         <p:spPr>
           <a:xfrm>
             <a:off x="685800" y="6458000"/>
-            <a:ext cx="10820400" cy="300000"/>
+            <a:ext cx="3000000" cy="300000"/>
           </a:xfrm>
           <a:prstGeom prst="rect">
             <a:avLst/>
@@ -6543,6 +6676,30 @@
           </a:p>
         </p:txBody>
       </p:sp>
+      <p:pic>
+        <p:nvPicPr>
+          <p:cNvPr id="6" name="Picture 5" descr="logo_mark.png"/>
+          <p:cNvPicPr>
+            <a:picLocks noChangeAspect="1"/>
+          </p:cNvPicPr>
+          <p:nvPr/>
+        </p:nvPicPr>
+        <p:blipFill>
+          <a:blip r:embed="rId2"/>
+          <a:stretch>
+            <a:fillRect/>
+          </a:stretch>
+        </p:blipFill>
+        <p:spPr>
+          <a:xfrm>
+            <a:off x="10986200" y="360000"/>
+            <a:ext cx="520000" cy="520000"/>
+          </a:xfrm>
+          <a:prstGeom prst="rect">
+            <a:avLst/>
+          </a:prstGeom>
+        </p:spPr>
+      </p:pic>
     </p:spTree>
   </p:cSld>
   <p:clrMapOvr>
@@ -6783,7 +6940,7 @@
         <p:spPr>
           <a:xfrm>
             <a:off x="685800" y="6458000"/>
-            <a:ext cx="10820400" cy="300000"/>
+            <a:ext cx="3000000" cy="300000"/>
           </a:xfrm>
           <a:prstGeom prst="rect">
             <a:avLst/>
@@ -6844,6 +7001,30 @@
           </a:p>
         </p:txBody>
       </p:sp>
+      <p:pic>
+        <p:nvPicPr>
+          <p:cNvPr id="6" name="Picture 5" descr="logo_mark.png"/>
+          <p:cNvPicPr>
+            <a:picLocks noChangeAspect="1"/>
+          </p:cNvPicPr>
+          <p:nvPr/>
+        </p:nvPicPr>
+        <p:blipFill>
+          <a:blip r:embed="rId2"/>
+          <a:stretch>
+            <a:fillRect/>
+          </a:stretch>
+        </p:blipFill>
+        <p:spPr>
+          <a:xfrm>
+            <a:off x="10986200" y="360000"/>
+            <a:ext cx="520000" cy="520000"/>
+          </a:xfrm>
+          <a:prstGeom prst="rect">
+            <a:avLst/>
+          </a:prstGeom>
+        </p:spPr>
+      </p:pic>
     </p:spTree>
   </p:cSld>
   <p:clrMapOvr>
@@ -7117,8 +7298,8 @@
         </p:nvSpPr>
         <p:spPr>
           <a:xfrm>
-            <a:off x="685800" y="6050000"/>
-            <a:ext cx="10820400" cy="900000"/>
+            <a:off x="685800" y="5980000"/>
+            <a:ext cx="10820400" cy="450000"/>
           </a:xfrm>
           <a:prstGeom prst="rect">
             <a:avLst/>
@@ -7133,7 +7314,7 @@
           <a:p>
             <a:pPr algn="l"/>
             <a:r>
-              <a:rPr sz="2000">
+              <a:rPr sz="1700">
                 <a:solidFill>
                   <a:srgbClr val="FF9800"/>
                 </a:solidFill>
@@ -7153,7 +7334,7 @@
         <p:spPr>
           <a:xfrm>
             <a:off x="685800" y="6458000"/>
-            <a:ext cx="10820400" cy="300000"/>
+            <a:ext cx="3000000" cy="300000"/>
           </a:xfrm>
           <a:prstGeom prst="rect">
             <a:avLst/>
@@ -7214,6 +7395,30 @@
           </a:p>
         </p:txBody>
       </p:sp>
+      <p:pic>
+        <p:nvPicPr>
+          <p:cNvPr id="8" name="Picture 7" descr="logo_mark.png"/>
+          <p:cNvPicPr>
+            <a:picLocks noChangeAspect="1"/>
+          </p:cNvPicPr>
+          <p:nvPr/>
+        </p:nvPicPr>
+        <p:blipFill>
+          <a:blip r:embed="rId2"/>
+          <a:stretch>
+            <a:fillRect/>
+          </a:stretch>
+        </p:blipFill>
+        <p:spPr>
+          <a:xfrm>
+            <a:off x="10986200" y="360000"/>
+            <a:ext cx="520000" cy="520000"/>
+          </a:xfrm>
+          <a:prstGeom prst="rect">
+            <a:avLst/>
+          </a:prstGeom>
+        </p:spPr>
+      </p:pic>
     </p:spTree>
   </p:cSld>
   <p:clrMapOvr>
@@ -7453,8 +7658,8 @@
         </p:nvSpPr>
         <p:spPr>
           <a:xfrm>
-            <a:off x="685800" y="6100000"/>
-            <a:ext cx="10820400" cy="900000"/>
+            <a:off x="685800" y="5950000"/>
+            <a:ext cx="10820400" cy="450000"/>
           </a:xfrm>
           <a:prstGeom prst="rect">
             <a:avLst/>
@@ -7469,7 +7674,7 @@
           <a:p>
             <a:pPr algn="l"/>
             <a:r>
-              <a:rPr sz="2000">
+              <a:rPr sz="1500">
                 <a:solidFill>
                   <a:srgbClr val="4E4643"/>
                 </a:solidFill>
@@ -7489,7 +7694,7 @@
         <p:spPr>
           <a:xfrm>
             <a:off x="685800" y="6458000"/>
-            <a:ext cx="10820400" cy="300000"/>
+            <a:ext cx="3000000" cy="300000"/>
           </a:xfrm>
           <a:prstGeom prst="rect">
             <a:avLst/>
@@ -7550,6 +7755,30 @@
           </a:p>
         </p:txBody>
       </p:sp>
+      <p:pic>
+        <p:nvPicPr>
+          <p:cNvPr id="7" name="Picture 6" descr="logo_mark.png"/>
+          <p:cNvPicPr>
+            <a:picLocks noChangeAspect="1"/>
+          </p:cNvPicPr>
+          <p:nvPr/>
+        </p:nvPicPr>
+        <p:blipFill>
+          <a:blip r:embed="rId2"/>
+          <a:stretch>
+            <a:fillRect/>
+          </a:stretch>
+        </p:blipFill>
+        <p:spPr>
+          <a:xfrm>
+            <a:off x="10986200" y="360000"/>
+            <a:ext cx="520000" cy="520000"/>
+          </a:xfrm>
+          <a:prstGeom prst="rect">
+            <a:avLst/>
+          </a:prstGeom>
+        </p:spPr>
+      </p:pic>
     </p:spTree>
   </p:cSld>
   <p:clrMapOvr>
@@ -7824,7 +8053,7 @@
         <p:spPr>
           <a:xfrm>
             <a:off x="685800" y="6458000"/>
-            <a:ext cx="10820400" cy="300000"/>
+            <a:ext cx="3000000" cy="300000"/>
           </a:xfrm>
           <a:prstGeom prst="rect">
             <a:avLst/>
@@ -7885,6 +8114,30 @@
           </a:p>
         </p:txBody>
       </p:sp>
+      <p:pic>
+        <p:nvPicPr>
+          <p:cNvPr id="7" name="Picture 6" descr="logo_mark.png"/>
+          <p:cNvPicPr>
+            <a:picLocks noChangeAspect="1"/>
+          </p:cNvPicPr>
+          <p:nvPr/>
+        </p:nvPicPr>
+        <p:blipFill>
+          <a:blip r:embed="rId2"/>
+          <a:stretch>
+            <a:fillRect/>
+          </a:stretch>
+        </p:blipFill>
+        <p:spPr>
+          <a:xfrm>
+            <a:off x="10986200" y="360000"/>
+            <a:ext cx="520000" cy="520000"/>
+          </a:xfrm>
+          <a:prstGeom prst="rect">
+            <a:avLst/>
+          </a:prstGeom>
+        </p:spPr>
+      </p:pic>
     </p:spTree>
   </p:cSld>
   <p:clrMapOvr>
@@ -8233,7 +8486,7 @@
         <p:spPr>
           <a:xfrm>
             <a:off x="685800" y="6458000"/>
-            <a:ext cx="10820400" cy="300000"/>
+            <a:ext cx="3000000" cy="300000"/>
           </a:xfrm>
           <a:prstGeom prst="rect">
             <a:avLst/>
@@ -8294,6 +8547,30 @@
           </a:p>
         </p:txBody>
       </p:sp>
+      <p:pic>
+        <p:nvPicPr>
+          <p:cNvPr id="7" name="Picture 6" descr="logo_mark.png"/>
+          <p:cNvPicPr>
+            <a:picLocks noChangeAspect="1"/>
+          </p:cNvPicPr>
+          <p:nvPr/>
+        </p:nvPicPr>
+        <p:blipFill>
+          <a:blip r:embed="rId2"/>
+          <a:stretch>
+            <a:fillRect/>
+          </a:stretch>
+        </p:blipFill>
+        <p:spPr>
+          <a:xfrm>
+            <a:off x="10986200" y="360000"/>
+            <a:ext cx="520000" cy="520000"/>
+          </a:xfrm>
+          <a:prstGeom prst="rect">
+            <a:avLst/>
+          </a:prstGeom>
+        </p:spPr>
+      </p:pic>
     </p:spTree>
   </p:cSld>
   <p:clrMapOvr>

</xml_diff>